<commit_message>
Publier le modele en etoile du Bloc 2 et ses preuves VM
</commit_message>
<xml_diff>
--- a/bloc2_architecture/Presentation_Bloc2_OSINT.pptx
+++ b/bloc2_architecture/Presentation_Bloc2_OSINT.pptx
@@ -2,19 +2,19 @@
 <file path=ppt/presentation.xml><?xml version="1.0" encoding="utf-8"?>
 <p:presentation xmlns:p="http://schemas.openxmlformats.org/presentationml/2006/main">
   <p:sldMasterIdLst>
-    <p:sldMasterId xmlns:r="http://schemas.openxmlformats.org/officeDocument/2006/relationships" id="2147483648" r:id="Rd4c7496e80e94eff"/>
+    <p:sldMasterId xmlns:r="http://schemas.openxmlformats.org/officeDocument/2006/relationships" id="2147483648" r:id="R8eec5fee6cb3447a"/>
   </p:sldMasterIdLst>
   <p:notesMasterIdLst>
-    <p:notesMasterId xmlns:r="http://schemas.openxmlformats.org/officeDocument/2006/relationships" r:id="R13e655fc4f3c475f"/>
+    <p:notesMasterId xmlns:r="http://schemas.openxmlformats.org/officeDocument/2006/relationships" r:id="Rceffa3f9f814440d"/>
   </p:notesMasterIdLst>
   <p:sldIdLst>
-    <p:sldId xmlns:r="http://schemas.openxmlformats.org/officeDocument/2006/relationships" id="256" r:id="R577e48c7588d4e44"/>
-    <p:sldId xmlns:r="http://schemas.openxmlformats.org/officeDocument/2006/relationships" id="257" r:id="R748e314e06604f11"/>
-    <p:sldId xmlns:r="http://schemas.openxmlformats.org/officeDocument/2006/relationships" id="258" r:id="R491ae7ee460c4524"/>
-    <p:sldId xmlns:r="http://schemas.openxmlformats.org/officeDocument/2006/relationships" id="259" r:id="R02fbf5edfa744b81"/>
-    <p:sldId xmlns:r="http://schemas.openxmlformats.org/officeDocument/2006/relationships" id="260" r:id="Ree84ca0bb17340a4"/>
-    <p:sldId xmlns:r="http://schemas.openxmlformats.org/officeDocument/2006/relationships" id="261" r:id="R32fbf0cf1096437d"/>
-    <p:sldId xmlns:r="http://schemas.openxmlformats.org/officeDocument/2006/relationships" id="262" r:id="R9c1ce9b856dc44c4"/>
+    <p:sldId xmlns:r="http://schemas.openxmlformats.org/officeDocument/2006/relationships" id="256" r:id="R8ce020da3d2349d3"/>
+    <p:sldId xmlns:r="http://schemas.openxmlformats.org/officeDocument/2006/relationships" id="257" r:id="R5ab2dda6d35c4714"/>
+    <p:sldId xmlns:r="http://schemas.openxmlformats.org/officeDocument/2006/relationships" id="258" r:id="R413c5cab11c14aeb"/>
+    <p:sldId xmlns:r="http://schemas.openxmlformats.org/officeDocument/2006/relationships" id="259" r:id="R0b497bc03db04b7b"/>
+    <p:sldId xmlns:r="http://schemas.openxmlformats.org/officeDocument/2006/relationships" id="260" r:id="Rf4958ca342c44241"/>
+    <p:sldId xmlns:r="http://schemas.openxmlformats.org/officeDocument/2006/relationships" id="261" r:id="R4c2f7fddbda64aef"/>
+    <p:sldId xmlns:r="http://schemas.openxmlformats.org/officeDocument/2006/relationships" id="262" r:id="Rde7505c130c240ff"/>
   </p:sldIdLst>
   <p:sldSz cx="12192000" cy="6858000"/>
   <p:notesSz cx="6858000" cy="9144000"/>
@@ -563,7 +563,27 @@
           <a:lstStyle xmlns:a="http://schemas.openxmlformats.org/drawingml/2006/main"/>
           <a:p xmlns:a="http://schemas.openxmlformats.org/drawingml/2006/main">
             <a:r>
-              <a:t>0:30 à 1:30. Le Bloc 3 produit un export figé. PostgreSQL fait autorité pour les identifiants et métadonnées ; MongoDB pour les documents chiffrés. Elasticsearch est un index dérivé reconstructible. scripts/infrastructure.py deploy prépare les secrets absents, valide Compose, construit l’image, attend les healthchecks et applique la migration additive. Deux passages ont été exécutés sur les volumes existants, dont un avec construction. Aucun corpus importé implicitement. Le dossier docker inclut la définition racine, sans duplication. Docker Desktop est un environnement virtualisé local ; aucun serveur virtuel autonome ou cloud n’a été provisionné. L’installation sur un poste vierge reste à vérifier. Sources : docker-compose.yml, docker/compose.yaml, scripts/infrastructure.py, Preuves/Complement_20261018/deploy_build.json.</a:t>
+              <a:t>0:30 à 1:30. Le Bloc 3 produit un export figé. PostgreSQL fait autorité pour les identifiants et métadonnées ; MongoDB pour les documents chiffrés. Elasticsearch est un index dérivé reconstructible. scripts/infrastructure.py deploy prépare les secrets absents, valide Compose, construit l’image, attend les healthchecks et applique la migration additive. Deux passages ont été exécutés sur les volumes existants, dont un avec construction. Aucun corpus importé implicitement. Le dossier docker inclut la définition racine, sans duplication. Une VM Ubuntu locale dédiée est déployée depuis le 18 octobre : trois services, 100 fixtures et persistance après redémarrage vérifiés. L’installation sur un poste vierge reste à vérifier. Sources : docker-compose.yml, docker/compose.yaml, scripts/infrastructure.py, Preuves/Complement_20261018/deploy_build.json.</a:t>
+            </a:r>
+          </a:p>
+          <a:p xmlns:a="http://schemas.openxmlformats.org/drawingml/2006/main">
+            <a:r>
+              <a:t/>
+            </a:r>
+          </a:p>
+          <a:p xmlns:a="http://schemas.openxmlformats.org/drawingml/2006/main">
+            <a:r>
+              <a:t>Actualisation du 19 octobre : le modèle en étoile est ajouté à la page 3 et à la diapositive 3. Vues testées sur PostgreSQL isolé puis déployées dans la VM sur 100 documents fictifs. Preuves VM distinctes : Preuves/VM_20261018/Validation_VM_Bloc2.json.</a:t>
+            </a:r>
+          </a:p>
+          <a:p xmlns:a="http://schemas.openxmlformats.org/drawingml/2006/main">
+            <a:r>
+              <a:t/>
+            </a:r>
+          </a:p>
+          <a:p xmlns:a="http://schemas.openxmlformats.org/drawingml/2006/main">
+            <a:r>
+              <a:t>Preuve de déploiement du 19 octobre : Preuves/Etoile_VM_20261019/Verification_etoile_VM.json. Requête sans données fictives : zéro ligne attendu, aucun corpus réel dans la VM. HTTPS, SQL/MongoDB et TLS vérifiés après application.</a:t>
             </a:r>
           </a:p>
         </p:txBody>
@@ -633,7 +653,7 @@
           <a:lstStyle xmlns:a="http://schemas.openxmlformats.org/drawingml/2006/main"/>
           <a:p xmlns:a="http://schemas.openxmlformats.org/drawingml/2006/main">
             <a:r>
-              <a:t>1:30 à 2:10 (40 secondes)</a:t>
+              <a:t>1:30 à 2:10 (40 secondes prévues). L’ERD garde les tables opérationnelles et MongoDB les textes chiffrés. L’étoile analytique est centrée sur un article courant, relié à date_key, source_id et run_id. La mesure article_count vaut un. Les vues évitent de recopier les textes et ignorent les révisions et identifiants exclus. La somme compte des articles du corpus, pas des faits militaires. La date est calculée en UTC. Huit tests isolés passent, dont droits, suppression et absence de double comptage. Les quatre vues sont déployées dans la VM : 100 faits distincts et 100 lignes après jointure, UTC et droits SELECT vérifiés, tables opérationnelles inchangées.</a:t>
             </a:r>
           </a:p>
           <a:p xmlns:a="http://schemas.openxmlformats.org/drawingml/2006/main">
@@ -643,7 +663,7 @@
           </a:p>
           <a:p xmlns:a="http://schemas.openxmlformats.org/drawingml/2006/main">
             <a:r>
-              <a:t>Le schéma relationnel porte des clés primaires et des clés étrangères. Les révisions SQL archivent les métadonnées précédentes, avec une clé composée empêchant une archive dupliquée au rejeu. MongoDB porte documents et document_revisions avec un validateur JSON. L’identifiant et l’empreinte partagés permettent un contrôle de cohérence entre moteurs. Une écriture Mongo précède le commit SQL et le checkpoint. Il n’existe pas de transaction distribuée. Un lot incomplet se rejoue avant publication. Le registre des effacements bloque le réimport. Pour les dates, la sélection utilise les jours de publication inclusifs en UTC.</a:t>
+              <a:t>Sources : sql/03_analytics_star.sql ; docs/star_schema.dbml ; docs/star_schema.mmd ; docs/analytics_example.sql ; Preuves/Etoile_20261019/Tests_etoile.json ; rapport p. 3. Les PK/FK des vues sont logiques, héritées des contraintes de l’ERD. Aucun historique analytique ni entrepôt matérialisé.</a:t>
             </a:r>
           </a:p>
           <a:p xmlns:a="http://schemas.openxmlformats.org/drawingml/2006/main">
@@ -653,32 +673,7 @@
           </a:p>
           <a:p xmlns:a="http://schemas.openxmlformats.org/drawingml/2006/main">
             <a:r>
-              <a:t>Preuves et sources locales :</a:t>
-            </a:r>
-          </a:p>
-          <a:p xmlns:a="http://schemas.openxmlformats.org/drawingml/2006/main">
-            <a:r>
-              <a:t>/Users/ed/Desktop/Mémoire/02_Bloc_2_Architecture/sql/01_schema.sql</a:t>
-            </a:r>
-          </a:p>
-          <a:p xmlns:a="http://schemas.openxmlformats.org/drawingml/2006/main">
-            <a:r>
-              <a:t>/Users/ed/Desktop/Mémoire/02_Bloc_2_Architecture/sql/02_revisions.sql</a:t>
-            </a:r>
-          </a:p>
-          <a:p xmlns:a="http://schemas.openxmlformats.org/drawingml/2006/main">
-            <a:r>
-              <a:t>/Users/ed/Desktop/Mémoire/02_Bloc_2_Architecture/docs/sql_schema.dbml</a:t>
-            </a:r>
-          </a:p>
-          <a:p xmlns:a="http://schemas.openxmlformats.org/drawingml/2006/main">
-            <a:r>
-              <a:t>/Users/ed/Desktop/Mémoire/02_Bloc_2_Architecture/docs/nosql_schema.json</a:t>
-            </a:r>
-          </a:p>
-          <a:p xmlns:a="http://schemas.openxmlformats.org/drawingml/2006/main">
-            <a:r>
-              <a:t>/Users/ed/Desktop/Mémoire/02_Bloc_2_Architecture/Preuves/Revisions_collecte_TASS.json</a:t>
+              <a:t>Questions : pourquoi ce grain ? Compter les articles actuels sans compter leurs révisions. Pourquoi des vues ? Réutiliser les autorités existantes et éviter une copie supplémentaire des données. Durée indicative, sans répétition humaine attestée.</a:t>
             </a:r>
           </a:p>
           <a:p xmlns:a="http://schemas.openxmlformats.org/drawingml/2006/main">
@@ -688,7 +683,7 @@
           </a:p>
           <a:p xmlns:a="http://schemas.openxmlformats.org/drawingml/2006/main">
             <a:r>
-              <a:t>Les temps sont prévus. Une répétition humaine reste à chronométrer.</a:t>
+              <a:t>Preuve de déploiement du 19 octobre : Preuves/Etoile_VM_20261019/Verification_etoile_VM.json. Requête sans données fictives : zéro ligne attendu, aucun corpus réel dans la VM. HTTPS, SQL/MongoDB et TLS vérifiés après application.</a:t>
             </a:r>
           </a:p>
         </p:txBody>
@@ -1088,7 +1083,7 @@
           </a:p>
           <a:p xmlns:a="http://schemas.openxmlformats.org/drawingml/2006/main">
             <a:r>
-              <a:t>Le projet démontre une infrastructure locale exécutée et documentée. Un seul hôte reste un point de défaillance. Aucune exploitation externe en production ni disponibilité contractuelle n’a été attestée. Les cinq articles nouveaux du raccordement n’ont pas d’inférence NER dans cette recette. Une collecte et un entraînement sont des opérations distinctes. Pour aller en exploitation, il faudra traiter l’hébergement, les sauvegardes hors machine, la rotation des clés et les mesures représentatives du parcours complet. La démarche SQL/NoSQL reprend le cours Data Architecture for AI de Mathieu Larboullet. L’adaptation et ce support ont été préparés avec l’assistance de Codex et restent à maîtriser par Edouard Cappaert. Questions possibles : pourquoi trois moteurs, que couvre exactement le secours, et que mesurent les six millions de lignes ? Les réponses et les limites se retrouvent dans le guide oral.</a:t>
+              <a:t>Le projet démontre une infrastructure locale exécutée et documentée. Un seul hôte reste un point de défaillance. Aucune exploitation externe en production ni disponibilité contractuelle n’a été attestée. Les cinq articles nouveaux du raccordement n’ont pas d’inférence NER dans cette recette. Une collecte et un entraînement sont des opérations distinctes. Pour aller en exploitation, il faudra compléter les sauvegardes hors machine, la rotation des clés et les mesures représentatives du parcours complet. La démarche SQL/NoSQL reprend le cours Data Architecture for AI de Mathieu Larboullet. L’adaptation et ce support ont été préparés avec l’assistance de Codex et restent à maîtriser par Edouard Cappaert. Questions possibles : pourquoi trois moteurs, que couvre exactement le secours, et que mesurent les six millions de lignes ? Les réponses et les limites se retrouvent dans le guide oral.</a:t>
             </a:r>
           </a:p>
           <a:p xmlns:a="http://schemas.openxmlformats.org/drawingml/2006/main">
@@ -1129,6 +1124,26 @@
           <a:p xmlns:a="http://schemas.openxmlformats.org/drawingml/2006/main">
             <a:r>
               <a:t>Les temps sont prévus. Une répétition humaine reste à chronométrer.</a:t>
+            </a:r>
+          </a:p>
+          <a:p xmlns:a="http://schemas.openxmlformats.org/drawingml/2006/main">
+            <a:r>
+              <a:t/>
+            </a:r>
+          </a:p>
+          <a:p xmlns:a="http://schemas.openxmlformats.org/drawingml/2006/main">
+            <a:r>
+              <a:t>Actualisation du 19 octobre : le modèle en étoile est ajouté à la page 3 et à la diapositive 3. Vues testées sur PostgreSQL isolé puis déployées dans la VM sur 100 documents fictifs. Preuves VM distinctes : Preuves/VM_20261018/Validation_VM_Bloc2.json.</a:t>
+            </a:r>
+          </a:p>
+          <a:p xmlns:a="http://schemas.openxmlformats.org/drawingml/2006/main">
+            <a:r>
+              <a:t/>
+            </a:r>
+          </a:p>
+          <a:p xmlns:a="http://schemas.openxmlformats.org/drawingml/2006/main">
+            <a:r>
+              <a:t>Preuve de déploiement du 19 octobre : Preuves/Etoile_VM_20261019/Verification_etoile_VM.json. Requête sans données fictives : zéro ligne attendu, aucun corpus réel dans la VM. HTTPS, SQL/MongoDB et TLS vérifiés après application.</a:t>
             </a:r>
           </a:p>
         </p:txBody>
@@ -1196,7 +1211,7 @@
   </p:cSld>
   <p:clrMap bg1="lt1" tx1="dk1" bg2="lt2" tx2="dk2" accent1="accent1" accent2="accent2" accent3="accent3" accent4="accent4" accent5="accent5" accent6="accent6" hlink="hlink" folHlink="folHlink"/>
   <p:sldLayoutIdLst>
-    <p:sldLayoutId xmlns:r="http://schemas.openxmlformats.org/officeDocument/2006/relationships" id="2147483649" r:id="R29a86c0c61174f64"/>
+    <p:sldLayoutId xmlns:r="http://schemas.openxmlformats.org/officeDocument/2006/relationships" id="2147483649" r:id="R0321630d96254d85"/>
   </p:sldLayoutIdLst>
   <p:txStyles>
     <p:titleStyle>
@@ -2133,7 +2148,7 @@
                 <a:ea typeface="Arial"/>
                 <a:cs typeface="Arial"/>
               </a:rPr>
-              <a:t>Edouard Cappaert · Soutenance du mémoire · 18 octobre 2026</a:t>
+              <a:t>Edouard Cappaert · Soutenance du mémoire · 19 octobre 2026</a:t>
             </a:r>
           </a:p>
         </p:txBody>
@@ -2278,7 +2293,7 @@
                 <a:ea typeface="Arial"/>
                 <a:cs typeface="Arial"/>
               </a:rPr>
-              <a:t>Edouard Cappaert · Bloc 2 · 18 octobre 2026 · 2 / 7</a:t>
+              <a:t>Edouard Cappaert · Bloc 2 · 19 octobre 2026 · 2 / 7</a:t>
             </a:r>
           </a:p>
         </p:txBody>
@@ -2346,7 +2361,7 @@
           <p:cNvPr id="8" name="">
             <a:extLst xmlns:a="http://schemas.openxmlformats.org/drawingml/2006/main">
               <a:ext uri="{FF2B5EF4-FFF2-40B4-BE49-F238E27FC236}">
-                <a16:creationId xmlns:a16="http://schemas.microsoft.com/office/drawing/2014/main" id="{45E8B61F-4878-47A2-81A4-A2DA3F3F7069}"/>
+                <a16:creationId xmlns:a16="http://schemas.microsoft.com/office/drawing/2014/main" id="{2E7DE912-F1BF-407C-89D5-738B88A887EB}"/>
               </a:ext>
             </a:extLst>
           </p:cNvPr>
@@ -2356,7 +2371,7 @@
           <p:nvPr/>
         </p:nvPicPr>
         <p:blipFill>
-          <a:blip xmlns:r="http://schemas.openxmlformats.org/officeDocument/2006/relationships" xmlns:a="http://schemas.openxmlformats.org/drawingml/2006/main" r:embed="R455888f597f74ee4"/>
+          <a:blip xmlns:r="http://schemas.openxmlformats.org/officeDocument/2006/relationships" xmlns:a="http://schemas.openxmlformats.org/drawingml/2006/main" r:embed="R4a7c335a9d304779"/>
           <a:stretch xmlns:a="http://schemas.openxmlformats.org/drawingml/2006/main"/>
         </p:blipFill>
         <p:spPr>
@@ -2451,7 +2466,7 @@
                 <a:ea typeface="Arial"/>
                 <a:cs typeface="Arial"/>
               </a:rPr>
-              <a:t>Un identifiant relie SQL et MongoDB</a:t>
+              <a:t>SQL : ERD et étoile analytique</a:t>
             </a:r>
           </a:p>
         </p:txBody>
@@ -2509,7 +2524,7 @@
                 <a:ea typeface="Arial"/>
                 <a:cs typeface="Arial"/>
               </a:rPr>
-              <a:t>Edouard Cappaert · Bloc 2 · 18 octobre 2026 · 3 / 7</a:t>
+              <a:t>Edouard Cappaert · Bloc 2 · 19 octobre 2026 · 3 / 7</a:t>
             </a:r>
           </a:p>
         </p:txBody>
@@ -2519,7 +2534,7 @@
           <p:cNvPr id="8" name="">
             <a:extLst xmlns:a="http://schemas.openxmlformats.org/drawingml/2006/main">
               <a:ext uri="{FF2B5EF4-FFF2-40B4-BE49-F238E27FC236}">
-                <a16:creationId xmlns:a16="http://schemas.microsoft.com/office/drawing/2014/main" id="{3B1D368B-435F-4B21-966B-20A6E18360FA}"/>
+                <a16:creationId xmlns:a16="http://schemas.microsoft.com/office/drawing/2014/main" id="{62FB66ED-85FE-4D8E-82EC-C0D9AF106041}"/>
               </a:ext>
             </a:extLst>
           </p:cNvPr>
@@ -2554,7 +2569,7 @@
                           <a:ea typeface="Arial"/>
                           <a:cs typeface="Arial"/>
                         </a:rPr>
-                        <a:t>Entité SQL</a:t>
+                        <a:t>Vue analytique</a:t>
                       </a:r>
                     </a:p>
                   </a:txBody>
@@ -2578,7 +2593,7 @@
                           <a:ea typeface="Arial"/>
                           <a:cs typeface="Arial"/>
                         </a:rPr>
-                        <a:t>Clé et relations</a:t>
+                        <a:t>Clé logique</a:t>
                       </a:r>
                     </a:p>
                   </a:txBody>
@@ -2602,7 +2617,7 @@
                           <a:ea typeface="Arial"/>
                           <a:cs typeface="Arial"/>
                         </a:rPr>
-                        <a:t>Rôle</a:t>
+                        <a:t>Lecture</a:t>
                       </a:r>
                     </a:p>
                   </a:txBody>
@@ -2628,7 +2643,155 @@
                           <a:ea typeface="Arial"/>
                           <a:cs typeface="Arial"/>
                         </a:rPr>
-                        <a:t>sources</a:t>
+                        <a:t>fact_article</a:t>
+                      </a:r>
+                    </a:p>
+                  </a:txBody>
+                  <a:tcPr marL="133350" marR="133350" marT="114300" marB="114300" anchor="ctr">
+                    <a:solidFill>
+                      <a:srgbClr val="FFFFFF"/>
+                    </a:solidFill>
+                  </a:tcPr>
+                </a:tc>
+                <a:tc>
+                  <a:txBody>
+                    <a:bodyPr/>
+                    <a:lstStyle/>
+                    <a:p>
+                      <a:r>
+                        <a:rPr sz="1800" b="0">
+                          <a:solidFill>
+                            <a:srgbClr val="14303E"/>
+                          </a:solidFill>
+                          <a:latin typeface="Arial"/>
+                          <a:ea typeface="Arial"/>
+                          <a:cs typeface="Arial"/>
+                        </a:rPr>
+                        <a:t>article_id</a:t>
+                      </a:r>
+                    </a:p>
+                  </a:txBody>
+                  <a:tcPr marL="133350" marR="133350" marT="114300" marB="114300" anchor="ctr">
+                    <a:solidFill>
+                      <a:srgbClr val="FFFFFF"/>
+                    </a:solidFill>
+                  </a:tcPr>
+                </a:tc>
+                <a:tc>
+                  <a:txBody>
+                    <a:bodyPr/>
+                    <a:lstStyle/>
+                    <a:p>
+                      <a:r>
+                        <a:rPr sz="1800" b="0">
+                          <a:solidFill>
+                            <a:srgbClr val="14303E"/>
+                          </a:solidFill>
+                          <a:latin typeface="Arial"/>
+                          <a:ea typeface="Arial"/>
+                          <a:cs typeface="Arial"/>
+                        </a:rPr>
+                        <a:t>1 article courant, mesure = 1</a:t>
+                      </a:r>
+                    </a:p>
+                  </a:txBody>
+                  <a:tcPr marL="133350" marR="133350" marT="114300" marB="114300" anchor="ctr">
+                    <a:solidFill>
+                      <a:srgbClr val="FFFFFF"/>
+                    </a:solidFill>
+                  </a:tcPr>
+                </a:tc>
+              </a:tr>
+              <a:tr h="661035">
+                <a:tc>
+                  <a:txBody>
+                    <a:bodyPr/>
+                    <a:lstStyle/>
+                    <a:p>
+                      <a:r>
+                        <a:rPr sz="1800" b="0">
+                          <a:solidFill>
+                            <a:srgbClr val="14303E"/>
+                          </a:solidFill>
+                          <a:latin typeface="Arial"/>
+                          <a:ea typeface="Arial"/>
+                          <a:cs typeface="Arial"/>
+                        </a:rPr>
+                        <a:t>dim_date</a:t>
+                      </a:r>
+                    </a:p>
+                  </a:txBody>
+                  <a:tcPr marL="133350" marR="133350" marT="114300" marB="114300" anchor="ctr">
+                    <a:solidFill>
+                      <a:srgbClr val="F4F7F9"/>
+                    </a:solidFill>
+                  </a:tcPr>
+                </a:tc>
+                <a:tc>
+                  <a:txBody>
+                    <a:bodyPr/>
+                    <a:lstStyle/>
+                    <a:p>
+                      <a:r>
+                        <a:rPr sz="1800" b="0">
+                          <a:solidFill>
+                            <a:srgbClr val="14303E"/>
+                          </a:solidFill>
+                          <a:latin typeface="Arial"/>
+                          <a:ea typeface="Arial"/>
+                          <a:cs typeface="Arial"/>
+                        </a:rPr>
+                        <a:t>date_key</a:t>
+                      </a:r>
+                    </a:p>
+                  </a:txBody>
+                  <a:tcPr marL="133350" marR="133350" marT="114300" marB="114300" anchor="ctr">
+                    <a:solidFill>
+                      <a:srgbClr val="F4F7F9"/>
+                    </a:solidFill>
+                  </a:tcPr>
+                </a:tc>
+                <a:tc>
+                  <a:txBody>
+                    <a:bodyPr/>
+                    <a:lstStyle/>
+                    <a:p>
+                      <a:r>
+                        <a:rPr sz="1800" b="0">
+                          <a:solidFill>
+                            <a:srgbClr val="14303E"/>
+                          </a:solidFill>
+                          <a:latin typeface="Arial"/>
+                          <a:ea typeface="Arial"/>
+                          <a:cs typeface="Arial"/>
+                        </a:rPr>
+                        <a:t>Année, mois, jour UTC</a:t>
+                      </a:r>
+                    </a:p>
+                  </a:txBody>
+                  <a:tcPr marL="133350" marR="133350" marT="114300" marB="114300" anchor="ctr">
+                    <a:solidFill>
+                      <a:srgbClr val="F4F7F9"/>
+                    </a:solidFill>
+                  </a:tcPr>
+                </a:tc>
+              </a:tr>
+              <a:tr h="661035">
+                <a:tc>
+                  <a:txBody>
+                    <a:bodyPr/>
+                    <a:lstStyle/>
+                    <a:p>
+                      <a:r>
+                        <a:rPr sz="1800" b="0">
+                          <a:solidFill>
+                            <a:srgbClr val="14303E"/>
+                          </a:solidFill>
+                          <a:latin typeface="Arial"/>
+                          <a:ea typeface="Arial"/>
+                          <a:cs typeface="Arial"/>
+                        </a:rPr>
+                        <a:t>dim_source</a:t>
                       </a:r>
                     </a:p>
                   </a:txBody>
@@ -2676,7 +2839,7 @@
                           <a:ea typeface="Arial"/>
                           <a:cs typeface="Arial"/>
                         </a:rPr>
-                        <a:t>Origine des articles</a:t>
+                        <a:t>Origine de publication</a:t>
                       </a:r>
                     </a:p>
                   </a:txBody>
@@ -2702,7 +2865,7 @@
                           <a:ea typeface="Arial"/>
                           <a:cs typeface="Arial"/>
                         </a:rPr>
-                        <a:t>runs</a:t>
+                        <a:t>dim_execution</a:t>
                       </a:r>
                     </a:p>
                   </a:txBody>
@@ -2750,155 +2913,7 @@
                           <a:ea typeface="Arial"/>
                           <a:cs typeface="Arial"/>
                         </a:rPr>
-                        <a:t>Exécution et point de reprise</a:t>
-                      </a:r>
-                    </a:p>
-                  </a:txBody>
-                  <a:tcPr marL="133350" marR="133350" marT="114300" marB="114300" anchor="ctr">
-                    <a:solidFill>
-                      <a:srgbClr val="F4F7F9"/>
-                    </a:solidFill>
-                  </a:tcPr>
-                </a:tc>
-              </a:tr>
-              <a:tr h="661035">
-                <a:tc>
-                  <a:txBody>
-                    <a:bodyPr/>
-                    <a:lstStyle/>
-                    <a:p>
-                      <a:r>
-                        <a:rPr sz="1800" b="0">
-                          <a:solidFill>
-                            <a:srgbClr val="14303E"/>
-                          </a:solidFill>
-                          <a:latin typeface="Arial"/>
-                          <a:ea typeface="Arial"/>
-                          <a:cs typeface="Arial"/>
-                        </a:rPr>
-                        <a:t>articles</a:t>
-                      </a:r>
-                    </a:p>
-                  </a:txBody>
-                  <a:tcPr marL="133350" marR="133350" marT="114300" marB="114300" anchor="ctr">
-                    <a:solidFill>
-                      <a:srgbClr val="FFFFFF"/>
-                    </a:solidFill>
-                  </a:tcPr>
-                </a:tc>
-                <a:tc>
-                  <a:txBody>
-                    <a:bodyPr/>
-                    <a:lstStyle/>
-                    <a:p>
-                      <a:r>
-                        <a:rPr sz="1800" b="0">
-                          <a:solidFill>
-                            <a:srgbClr val="14303E"/>
-                          </a:solidFill>
-                          <a:latin typeface="Arial"/>
-                          <a:ea typeface="Arial"/>
-                          <a:cs typeface="Arial"/>
-                        </a:rPr>
-                        <a:t>article_id, source_id, run_id</a:t>
-                      </a:r>
-                    </a:p>
-                  </a:txBody>
-                  <a:tcPr marL="133350" marR="133350" marT="114300" marB="114300" anchor="ctr">
-                    <a:solidFill>
-                      <a:srgbClr val="FFFFFF"/>
-                    </a:solidFill>
-                  </a:tcPr>
-                </a:tc>
-                <a:tc>
-                  <a:txBody>
-                    <a:bodyPr/>
-                    <a:lstStyle/>
-                    <a:p>
-                      <a:r>
-                        <a:rPr sz="1800" b="0">
-                          <a:solidFill>
-                            <a:srgbClr val="14303E"/>
-                          </a:solidFill>
-                          <a:latin typeface="Arial"/>
-                          <a:ea typeface="Arial"/>
-                          <a:cs typeface="Arial"/>
-                        </a:rPr>
-                        <a:t>Dates et empreinte du contenu</a:t>
-                      </a:r>
-                    </a:p>
-                  </a:txBody>
-                  <a:tcPr marL="133350" marR="133350" marT="114300" marB="114300" anchor="ctr">
-                    <a:solidFill>
-                      <a:srgbClr val="FFFFFF"/>
-                    </a:solidFill>
-                  </a:tcPr>
-                </a:tc>
-              </a:tr>
-              <a:tr h="661035">
-                <a:tc>
-                  <a:txBody>
-                    <a:bodyPr/>
-                    <a:lstStyle/>
-                    <a:p>
-                      <a:r>
-                        <a:rPr sz="1800" b="0">
-                          <a:solidFill>
-                            <a:srgbClr val="14303E"/>
-                          </a:solidFill>
-                          <a:latin typeface="Arial"/>
-                          <a:ea typeface="Arial"/>
-                          <a:cs typeface="Arial"/>
-                        </a:rPr>
-                        <a:t>article_revisions</a:t>
-                      </a:r>
-                    </a:p>
-                  </a:txBody>
-                  <a:tcPr marL="133350" marR="133350" marT="114300" marB="114300" anchor="ctr">
-                    <a:solidFill>
-                      <a:srgbClr val="F4F7F9"/>
-                    </a:solidFill>
-                  </a:tcPr>
-                </a:tc>
-                <a:tc>
-                  <a:txBody>
-                    <a:bodyPr/>
-                    <a:lstStyle/>
-                    <a:p>
-                      <a:r>
-                        <a:rPr sz="1800" b="0">
-                          <a:solidFill>
-                            <a:srgbClr val="14303E"/>
-                          </a:solidFill>
-                          <a:latin typeface="Arial"/>
-                          <a:ea typeface="Arial"/>
-                          <a:cs typeface="Arial"/>
-                        </a:rPr>
-                        <a:t>article_id + content_sha256</a:t>
-                      </a:r>
-                    </a:p>
-                  </a:txBody>
-                  <a:tcPr marL="133350" marR="133350" marT="114300" marB="114300" anchor="ctr">
-                    <a:solidFill>
-                      <a:srgbClr val="F4F7F9"/>
-                    </a:solidFill>
-                  </a:tcPr>
-                </a:tc>
-                <a:tc>
-                  <a:txBody>
-                    <a:bodyPr/>
-                    <a:lstStyle/>
-                    <a:p>
-                      <a:r>
-                        <a:rPr sz="1800" b="0">
-                          <a:solidFill>
-                            <a:srgbClr val="14303E"/>
-                          </a:solidFill>
-                          <a:latin typeface="Arial"/>
-                          <a:ea typeface="Arial"/>
-                          <a:cs typeface="Arial"/>
-                        </a:rPr>
-                        <a:t>Métadonnées précédentes</a:t>
+                        <a:t>Provenance de l’ingestion</a:t>
                       </a:r>
                     </a:p>
                   </a:txBody>
@@ -2966,7 +2981,7 @@
                 <a:ea typeface="Arial"/>
                 <a:cs typeface="Arial"/>
               </a:rPr>
-              <a:t>MongoDB conserve le JSON et les révisions du texte chiffré</a:t>
+              <a:t>L’ERD reste opérationnel ; MongoDB garde les textes chiffrés</a:t>
             </a:r>
           </a:p>
         </p:txBody>
@@ -3024,7 +3039,7 @@
                 <a:ea typeface="Arial"/>
                 <a:cs typeface="Arial"/>
               </a:rPr>
-              <a:t>Identifiant et empreinte communs. Le rejeu évite les doublons.</a:t>
+              <a:t>Vues dérivées, sans texte ni copie historique.</a:t>
             </a:r>
           </a:p>
           <a:p xmlns:a="http://schemas.openxmlformats.org/drawingml/2006/main">
@@ -3048,7 +3063,7 @@
                 <a:ea typeface="Arial"/>
                 <a:cs typeface="Arial"/>
               </a:rPr>
-              <a:t>Le registre erasures conserve les exclusions après effacement.</a:t>
+              <a:t>VM : 100 articles fictifs, jointures et droits vérifiés.</a:t>
             </a:r>
           </a:p>
         </p:txBody>
@@ -3193,7 +3208,7 @@
                 <a:ea typeface="Arial"/>
                 <a:cs typeface="Arial"/>
               </a:rPr>
-              <a:t>Edouard Cappaert · Bloc 2 · 18 octobre 2026 · 4 / 7</a:t>
+              <a:t>Edouard Cappaert · Bloc 2 · 19 octobre 2026 · 4 / 7</a:t>
             </a:r>
           </a:p>
         </p:txBody>
@@ -3203,7 +3218,7 @@
           <p:cNvPr id="7" name="">
             <a:extLst xmlns:a="http://schemas.openxmlformats.org/drawingml/2006/main">
               <a:ext uri="{FF2B5EF4-FFF2-40B4-BE49-F238E27FC236}">
-                <a16:creationId xmlns:a16="http://schemas.microsoft.com/office/drawing/2014/main" id="{D97BEDE5-574C-49CC-A4C9-97C5AB07DFA2}"/>
+                <a16:creationId xmlns:a16="http://schemas.microsoft.com/office/drawing/2014/main" id="{07336D9B-867B-4105-BB8A-055CBF1E93F8}"/>
               </a:ext>
             </a:extLst>
           </p:cNvPr>
@@ -3795,7 +3810,7 @@
                 <a:ea typeface="Arial"/>
                 <a:cs typeface="Arial"/>
               </a:rPr>
-              <a:t>Edouard Cappaert · Bloc 2 · 18 octobre 2026 · 5 / 7</a:t>
+              <a:t>Edouard Cappaert · Bloc 2 · 19 octobre 2026 · 5 / 7</a:t>
             </a:r>
           </a:p>
         </p:txBody>
@@ -3805,7 +3820,7 @@
           <p:cNvPr id="10" name="">
             <a:extLst xmlns:a="http://schemas.openxmlformats.org/drawingml/2006/main">
               <a:ext uri="{FF2B5EF4-FFF2-40B4-BE49-F238E27FC236}">
-                <a16:creationId xmlns:a16="http://schemas.microsoft.com/office/drawing/2014/main" id="{5FB72528-F9D7-4CCF-9989-22EDD589D0BE}"/>
+                <a16:creationId xmlns:a16="http://schemas.microsoft.com/office/drawing/2014/main" id="{992B50DB-A599-45CF-A78A-CF9EA4777864}"/>
               </a:ext>
             </a:extLst>
           </p:cNvPr>
@@ -4033,7 +4048,7 @@
           <p:cNvPr id="11" name="">
             <a:extLst xmlns:a="http://schemas.openxmlformats.org/drawingml/2006/main">
               <a:ext uri="{FF2B5EF4-FFF2-40B4-BE49-F238E27FC236}">
-                <a16:creationId xmlns:a16="http://schemas.microsoft.com/office/drawing/2014/main" id="{0961B9F9-88D4-4F15-A0A8-1717F3A88EEF}"/>
+                <a16:creationId xmlns:a16="http://schemas.microsoft.com/office/drawing/2014/main" id="{42C07E63-D63E-455C-A88D-1B29A362D7CC}"/>
               </a:ext>
             </a:extLst>
           </p:cNvPr>
@@ -4043,7 +4058,7 @@
           <p:nvPr/>
         </p:nvPicPr>
         <p:blipFill>
-          <a:blip xmlns:r="http://schemas.openxmlformats.org/officeDocument/2006/relationships" xmlns:a="http://schemas.openxmlformats.org/drawingml/2006/main" r:embed="R48f4c9cf8d14415a"/>
+          <a:blip xmlns:r="http://schemas.openxmlformats.org/officeDocument/2006/relationships" xmlns:a="http://schemas.openxmlformats.org/drawingml/2006/main" r:embed="Rcbef0c957fe5475b"/>
           <a:srcRect xmlns:a="http://schemas.openxmlformats.org/drawingml/2006/main" l="0" t="55" r="0" b="55"/>
           <a:stretch xmlns:a="http://schemas.openxmlformats.org/drawingml/2006/main">
             <a:fillRect l="0" t="0" r="0" b="0"/>
@@ -4397,7 +4412,7 @@
                 <a:ea typeface="Arial"/>
                 <a:cs typeface="Arial"/>
               </a:rPr>
-              <a:t>Edouard Cappaert · Bloc 2 · 18 octobre 2026 · 6 / 7</a:t>
+              <a:t>Edouard Cappaert · Bloc 2 · 19 octobre 2026 · 6 / 7</a:t>
             </a:r>
           </a:p>
         </p:txBody>
@@ -4407,7 +4422,7 @@
           <p:cNvPr id="12" name="">
             <a:extLst xmlns:a="http://schemas.openxmlformats.org/drawingml/2006/main">
               <a:ext uri="{FF2B5EF4-FFF2-40B4-BE49-F238E27FC236}">
-                <a16:creationId xmlns:a16="http://schemas.microsoft.com/office/drawing/2014/main" id="{7172C26E-8FCF-49C2-A187-B5E1F4764AF1}"/>
+                <a16:creationId xmlns:a16="http://schemas.microsoft.com/office/drawing/2014/main" id="{A8DE49E4-8971-469C-BCF1-E5AE59BD2457}"/>
               </a:ext>
             </a:extLst>
           </p:cNvPr>
@@ -4417,7 +4432,7 @@
           <p:nvPr/>
         </p:nvPicPr>
         <p:blipFill>
-          <a:blip xmlns:r="http://schemas.openxmlformats.org/officeDocument/2006/relationships" xmlns:a="http://schemas.openxmlformats.org/drawingml/2006/main" r:embed="Rd2547accf3a64a72"/>
+          <a:blip xmlns:r="http://schemas.openxmlformats.org/officeDocument/2006/relationships" xmlns:a="http://schemas.openxmlformats.org/drawingml/2006/main" r:embed="R9ba759b008824490"/>
           <a:stretch xmlns:a="http://schemas.openxmlformats.org/drawingml/2006/main"/>
         </p:blipFill>
         <p:spPr>
@@ -4966,7 +4981,7 @@
                 <a:ea typeface="Arial"/>
                 <a:cs typeface="Arial"/>
               </a:rPr>
-              <a:t>Edouard Cappaert · Bloc 2 · 18 octobre 2026 · 7 / 7</a:t>
+              <a:t>Edouard Cappaert · Bloc 2 · 19 octobre 2026 · 7 / 7</a:t>
             </a:r>
           </a:p>
         </p:txBody>
@@ -5082,7 +5097,7 @@
                 <a:ea typeface="Arial"/>
                 <a:cs typeface="Arial"/>
               </a:rPr>
-              <a:t>Déploiement, cohérence et surveillance locale</a:t>
+              <a:t>VM locale, cohérence et surveillance</a:t>
             </a:r>
           </a:p>
           <a:p xmlns:a="http://schemas.openxmlformats.org/drawingml/2006/main">
@@ -5246,7 +5261,7 @@
                 <a:ea typeface="Arial"/>
                 <a:cs typeface="Arial"/>
               </a:rPr>
-              <a:t>Serveur virtuel autonome et sauvegarde hors machine</a:t>
+              <a:t>Organiser une sauvegarde hors machine</a:t>
             </a:r>
           </a:p>
           <a:p xmlns:a="http://schemas.openxmlformats.org/drawingml/2006/main">

</xml_diff>